<commit_message>
analysis: add met LogReg kfold script and include in repeat_4fold PPT
New met_lgbm_logreg_kfold.py mirrors combined_kfold.py's exact fold
structure (SEED=1, all 139 organoids upfront, inner_tr_oids, fold_seed =
rep_seed + fold_i × 97) so results are directly comparable to the existing
LGBM met line. LogReg consistently matches or beats LGBM met (e.g. Dy08:
+0.12, Dy13: +0.12, Dy30: +0.03 BA). Both modalities now shown in
repeat_4fold_cv.pptx spaghetti and per-repeat line plots.

Co-Authored-By: Claude Sonnet 4.6 <noreply@anthropic.com>
</commit_message>
<xml_diff>
--- a/figures/repeat_4fold_cv.pptx
+++ b/figures/repeat_4fold_cv.pptx
@@ -3173,7 +3173,7 @@
                   <a:srgbClr val="BDD7EE"/>
                 </a:solidFill>
               </a:rPr>
-              <a:t>series_idor  ·  n=139  ·  Metabolite + Morphology + Image</a:t>
+              <a:t>series_idor  ·  n=139  ·  Metabolite (LGBM + LogReg) + Morphology + Image</a:t>
             </a:r>
           </a:p>
         </p:txBody>
@@ -4136,7 +4136,7 @@
         <p:spPr>
           <a:xfrm>
             <a:off x="320040" y="685800"/>
-            <a:ext cx="11430000" cy="3306913"/>
+            <a:ext cx="11430000" cy="2640645"/>
           </a:xfrm>
           <a:prstGeom prst="rect">
             <a:avLst/>

</xml_diff>